<commit_message>
add parsing demos to website and update cfg1 slides
</commit_message>
<xml_diff>
--- a/assets/ppt/cfg/cfg1-intro.pptx
+++ b/assets/ppt/cfg/cfg1-intro.pptx
@@ -25853,8 +25853,8 @@
           </p:txBody>
         </p:sp>
       </p:grpSp>
-      <mc:AlternateContent xmlns:mc="http://schemas.openxmlformats.org/markup-compatibility/2006">
-        <mc:Choice xmlns:a14="http://schemas.microsoft.com/office/drawing/2010/main" Requires="a14">
+      <mc:AlternateContent xmlns:mc="http://schemas.openxmlformats.org/markup-compatibility/2006" xmlns:a14="http://schemas.microsoft.com/office/drawing/2010/main">
+        <mc:Choice Requires="a14">
           <p:sp>
             <p:nvSpPr>
               <p:cNvPr id="15" name="Rectangle 14">
@@ -25977,7 +25977,7 @@
             </p:txBody>
           </p:sp>
         </mc:Choice>
-        <mc:Fallback>
+        <mc:Fallback xmlns="">
           <p:sp>
             <p:nvSpPr>
               <p:cNvPr id="15" name="Rectangle 14">
@@ -26400,51 +26400,6 @@
                       </p:childTnLst>
                     </p:cTn>
                   </p:par>
-                  <p:par>
-                    <p:cTn id="35" fill="hold">
-                      <p:stCondLst>
-                        <p:cond delay="indefinite"/>
-                      </p:stCondLst>
-                      <p:childTnLst>
-                        <p:par>
-                          <p:cTn id="36" fill="hold">
-                            <p:stCondLst>
-                              <p:cond delay="0"/>
-                            </p:stCondLst>
-                            <p:childTnLst>
-                              <p:par>
-                                <p:cTn id="37" presetID="1" presetClass="entr" presetSubtype="0" fill="hold" grpId="0" nodeType="clickEffect">
-                                  <p:stCondLst>
-                                    <p:cond delay="0"/>
-                                  </p:stCondLst>
-                                  <p:childTnLst>
-                                    <p:set>
-                                      <p:cBhvr>
-                                        <p:cTn id="38" dur="1" fill="hold">
-                                          <p:stCondLst>
-                                            <p:cond delay="0"/>
-                                          </p:stCondLst>
-                                        </p:cTn>
-                                        <p:tgtEl>
-                                          <p:spTgt spid="15"/>
-                                        </p:tgtEl>
-                                        <p:attrNameLst>
-                                          <p:attrName>style.visibility</p:attrName>
-                                        </p:attrNameLst>
-                                      </p:cBhvr>
-                                      <p:to>
-                                        <p:strVal val="visible"/>
-                                      </p:to>
-                                    </p:set>
-                                  </p:childTnLst>
-                                </p:cTn>
-                              </p:par>
-                            </p:childTnLst>
-                          </p:cTn>
-                        </p:par>
-                      </p:childTnLst>
-                    </p:cTn>
-                  </p:par>
                 </p:childTnLst>
               </p:cTn>
               <p:prevCondLst>
@@ -26471,7 +26426,6 @@
       <p:bldP spid="5" grpId="0"/>
       <p:bldP spid="6" grpId="0"/>
       <p:bldP spid="31" grpId="0" animBg="1"/>
-      <p:bldP spid="15" grpId="0"/>
     </p:bldLst>
   </p:timing>
 </p:sld>

</xml_diff>